<commit_message>
fix(instinct-demo): add inner ellipse for radial-gradient glow on title slide
Layer a second smaller, more opaque teal ellipse (88% transparency, 3"
diameter) inside the existing outer glow (94%, 6") to approximate a
radial gradient effect on the title slide.

Co-Authored-By: Claude Opus 4.7 (1M context) <noreply@anthropic.com>
</commit_message>
<xml_diff>
--- a/examples/instinct-demo/instinct-demo.pptx
+++ b/examples/instinct-demo/instinct-demo.pptx
@@ -2036,6 +2036,28 @@
         </p:nvSpPr>
         <p:spPr>
           <a:xfrm>
+            <a:off x="8503920" y="1828800"/>
+            <a:ext cx="2743200" cy="2743200"/>
+          </a:xfrm>
+          <a:prstGeom prst="ellipse">
+            <a:avLst/>
+          </a:prstGeom>
+          <a:solidFill>
+            <a:srgbClr val="00C2DE">
+              <a:alpha val="12000"/>
+            </a:srgbClr>
+          </a:solidFill>
+          <a:ln/>
+        </p:spPr>
+      </p:sp>
+      <p:sp>
+        <p:nvSpPr>
+          <p:cNvPr id="4" name="Shape 2"/>
+          <p:cNvSpPr/>
+          <p:nvPr/>
+        </p:nvSpPr>
+        <p:spPr>
+          <a:xfrm>
             <a:off x="585216" y="2331720"/>
             <a:ext cx="822960" cy="22860"/>
           </a:xfrm>
@@ -2050,7 +2072,7 @@
       </p:sp>
       <p:sp>
         <p:nvSpPr>
-          <p:cNvPr id="4" name="Text 2"/>
+          <p:cNvPr id="5" name="Text 3"/>
           <p:cNvSpPr/>
           <p:nvPr/>
         </p:nvSpPr>
@@ -2089,7 +2111,7 @@
       </p:sp>
       <p:sp>
         <p:nvSpPr>
-          <p:cNvPr id="5" name="Text 3"/>
+          <p:cNvPr id="6" name="Text 4"/>
           <p:cNvSpPr/>
           <p:nvPr/>
         </p:nvSpPr>
@@ -2151,7 +2173,7 @@
       </p:sp>
       <p:sp>
         <p:nvSpPr>
-          <p:cNvPr id="6" name="Shape 4"/>
+          <p:cNvPr id="7" name="Shape 5"/>
           <p:cNvSpPr/>
           <p:nvPr/>
         </p:nvSpPr>
@@ -2171,7 +2193,7 @@
       </p:sp>
       <p:sp>
         <p:nvSpPr>
-          <p:cNvPr id="7" name="Text 5"/>
+          <p:cNvPr id="8" name="Text 6"/>
           <p:cNvSpPr/>
           <p:nvPr/>
         </p:nvSpPr>
@@ -2233,7 +2255,7 @@
       </p:sp>
       <p:sp>
         <p:nvSpPr>
-          <p:cNvPr id="8" name="Text 6"/>
+          <p:cNvPr id="9" name="Text 7"/>
           <p:cNvSpPr/>
           <p:nvPr/>
         </p:nvSpPr>

</xml_diff>